<commit_message>
Update reporting prompt and slide deck
</commit_message>
<xml_diff>
--- a/challenge4_slides v2.pptx
+++ b/challenge4_slides v2.pptx
@@ -3343,7 +3343,7 @@
         <p:spPr>
           <a:xfrm>
             <a:off x="355600" y="1168400"/>
-            <a:ext cx="3708400" cy="2614460"/>
+            <a:ext cx="3708400" cy="2933874"/>
           </a:xfrm>
           <a:prstGeom prst="roundRect">
             <a:avLst>
@@ -3535,7 +3535,7 @@
         <p:spPr>
           <a:xfrm>
             <a:off x="4241800" y="1168400"/>
-            <a:ext cx="3708400" cy="2614460"/>
+            <a:ext cx="3708400" cy="2933874"/>
           </a:xfrm>
           <a:prstGeom prst="roundRect">
             <a:avLst>
@@ -3556,56 +3556,122 @@
           <a:lstStyle/>
           <a:p>
             <a:r>
-              <a:t>First Live Runs (demo placeholders)</a:t>
-            </a:r>
-          </a:p>
-          <a:p>
-            <a:r>
+              <a:rPr sz="1400" b="1" dirty="0">
+                <a:solidFill>
+                  <a:srgbClr val="002147"/>
+                </a:solidFill>
+                <a:latin typeface="Georgia"/>
+              </a:rPr>
+              <a:t>First Live Runs)</a:t>
+            </a:r>
+          </a:p>
+          <a:p>
+            <a:r>
+              <a:rPr sz="1200" dirty="0">
+                <a:solidFill>
+                  <a:srgbClr val="1C1C28"/>
+                </a:solidFill>
+                <a:latin typeface="Calibri"/>
+              </a:rPr>
               <a:t>Run 1</a:t>
             </a:r>
           </a:p>
           <a:p>
             <a:r>
+              <a:rPr sz="1200" dirty="0">
+                <a:solidFill>
+                  <a:srgbClr val="1C1C28"/>
+                </a:solidFill>
+                <a:latin typeface="Calibri"/>
+              </a:rPr>
               <a:t>Abnormal uploaded chest X-ray</a:t>
             </a:r>
           </a:p>
           <a:p>
             <a:r>
+              <a:rPr sz="1200" dirty="0">
+                <a:solidFill>
+                  <a:srgbClr val="1C1C28"/>
+                </a:solidFill>
+                <a:latin typeface="Calibri"/>
+              </a:rPr>
               <a:t>COVID-19 output (0.628 composite confidence)</a:t>
             </a:r>
           </a:p>
           <a:p>
             <a:r>
+              <a:rPr sz="1200" dirty="0">
+                <a:solidFill>
+                  <a:srgbClr val="1C1C28"/>
+                </a:solidFill>
+                <a:latin typeface="Calibri"/>
+              </a:rPr>
               <a:t>Top signals: Lung Opacity 0.698 | Mass 0.661 | Pneumothorax 0.641</a:t>
             </a:r>
           </a:p>
           <a:p>
             <a:r>
+              <a:rPr sz="1200" dirty="0">
+                <a:solidFill>
+                  <a:srgbClr val="1C1C28"/>
+                </a:solidFill>
+                <a:latin typeface="Calibri"/>
+              </a:rPr>
               <a:t>Run 2</a:t>
             </a:r>
           </a:p>
           <a:p>
             <a:r>
+              <a:rPr sz="1200" dirty="0">
+                <a:solidFill>
+                  <a:srgbClr val="1C1C28"/>
+                </a:solidFill>
+                <a:latin typeface="Calibri"/>
+              </a:rPr>
               <a:t>Likely normal uploaded chest X-ray</a:t>
             </a:r>
           </a:p>
           <a:p>
             <a:r>
+              <a:rPr sz="1200" dirty="0">
+                <a:solidFill>
+                  <a:srgbClr val="1C1C28"/>
+                </a:solidFill>
+                <a:latin typeface="Calibri"/>
+              </a:rPr>
               <a:t>COVID-19 output (0.630 composite confidence)</a:t>
             </a:r>
           </a:p>
           <a:p>
             <a:r>
+              <a:rPr sz="1200" dirty="0">
+                <a:solidFill>
+                  <a:srgbClr val="1C1C28"/>
+                </a:solidFill>
+                <a:latin typeface="Calibri"/>
+              </a:rPr>
               <a:t>Top signals: Infiltration 0.630 | Pneumothorax 0.575 | Consolidation 0.574</a:t>
             </a:r>
           </a:p>
           <a:p>
             <a:r>
+              <a:rPr sz="1200" dirty="0">
+                <a:solidFill>
+                  <a:srgbClr val="1C1C28"/>
+                </a:solidFill>
+                <a:latin typeface="Calibri"/>
+              </a:rPr>
               <a:t>Interpretation</a:t>
             </a:r>
           </a:p>
           <a:p>
             <a:r>
+              <a:rPr sz="1200" dirty="0">
+                <a:solidFill>
+                  <a:srgbClr val="1C1C28"/>
+                </a:solidFill>
+                <a:latin typeface="Calibri"/>
+              </a:rPr>
               <a:t>Diffuse, weakly separated outputs; useful for limitations and governance, not a clean performance win</a:t>
             </a:r>
           </a:p>
@@ -3620,7 +3686,7 @@
         <p:spPr>
           <a:xfrm>
             <a:off x="8128000" y="1168400"/>
-            <a:ext cx="3708400" cy="2614460"/>
+            <a:ext cx="3708400" cy="2933874"/>
           </a:xfrm>
           <a:prstGeom prst="roundRect">
             <a:avLst>
@@ -3759,7 +3825,7 @@
         </p:nvSpPr>
         <p:spPr>
           <a:xfrm>
-            <a:off x="355600" y="3993895"/>
+            <a:off x="355600" y="4281993"/>
             <a:ext cx="5651500" cy="1905000"/>
           </a:xfrm>
           <a:prstGeom prst="roundRect">
@@ -3878,7 +3944,7 @@
         </p:nvSpPr>
         <p:spPr>
           <a:xfrm>
-            <a:off x="6184900" y="3993895"/>
+            <a:off x="6184900" y="4281993"/>
             <a:ext cx="5651500" cy="1905000"/>
           </a:xfrm>
           <a:prstGeom prst="roundRect">
@@ -4724,7 +4790,7 @@
                 </a:solidFill>
                 <a:latin typeface="Calibri"/>
               </a:rPr>
-              <a:t>Systematic underdiagnosis: ♀, Black, Hispanic, Medicaid patients (Seyyed-Kalantari 2021)</a:t>
+              <a:t>Systematic underdiagnosis: ♀, Black, Hispanic, Medicaid patients (Seyyed-Kalantari 2021) **US ethnic groups??</a:t>
             </a:r>
           </a:p>
           <a:p>

</xml_diff>

<commit_message>
Add test_data set and latest app updates
</commit_message>
<xml_diff>
--- a/challenge4_slides v2.pptx
+++ b/challenge4_slides v2.pptx
@@ -304,7 +304,7 @@
           <a:p>
             <a:fld id="{5BCAD085-E8A6-8845-BD4E-CB4CCA059FC4}" type="datetimeFigureOut">
               <a:rPr lang="en-US" smtClean="0"/>
-              <a:t>4/7/2026</a:t>
+              <a:t>4/8/2026</a:t>
             </a:fld>
             <a:endParaRPr lang="en-US"/>
           </a:p>
@@ -472,7 +472,7 @@
           <a:p>
             <a:fld id="{5BCAD085-E8A6-8845-BD4E-CB4CCA059FC4}" type="datetimeFigureOut">
               <a:rPr lang="en-US" smtClean="0"/>
-              <a:t>4/7/2026</a:t>
+              <a:t>4/8/2026</a:t>
             </a:fld>
             <a:endParaRPr lang="en-US"/>
           </a:p>
@@ -650,7 +650,7 @@
           <a:p>
             <a:fld id="{5BCAD085-E8A6-8845-BD4E-CB4CCA059FC4}" type="datetimeFigureOut">
               <a:rPr lang="en-US" smtClean="0"/>
-              <a:t>4/7/2026</a:t>
+              <a:t>4/8/2026</a:t>
             </a:fld>
             <a:endParaRPr lang="en-US"/>
           </a:p>
@@ -818,7 +818,7 @@
           <a:p>
             <a:fld id="{5BCAD085-E8A6-8845-BD4E-CB4CCA059FC4}" type="datetimeFigureOut">
               <a:rPr lang="en-US" smtClean="0"/>
-              <a:t>4/7/2026</a:t>
+              <a:t>4/8/2026</a:t>
             </a:fld>
             <a:endParaRPr lang="en-US"/>
           </a:p>
@@ -1063,7 +1063,7 @@
           <a:p>
             <a:fld id="{5BCAD085-E8A6-8845-BD4E-CB4CCA059FC4}" type="datetimeFigureOut">
               <a:rPr lang="en-US" smtClean="0"/>
-              <a:t>4/7/2026</a:t>
+              <a:t>4/8/2026</a:t>
             </a:fld>
             <a:endParaRPr lang="en-US"/>
           </a:p>
@@ -1348,7 +1348,7 @@
           <a:p>
             <a:fld id="{5BCAD085-E8A6-8845-BD4E-CB4CCA059FC4}" type="datetimeFigureOut">
               <a:rPr lang="en-US" smtClean="0"/>
-              <a:t>4/7/2026</a:t>
+              <a:t>4/8/2026</a:t>
             </a:fld>
             <a:endParaRPr lang="en-US"/>
           </a:p>
@@ -1767,7 +1767,7 @@
           <a:p>
             <a:fld id="{5BCAD085-E8A6-8845-BD4E-CB4CCA059FC4}" type="datetimeFigureOut">
               <a:rPr lang="en-US" smtClean="0"/>
-              <a:t>4/7/2026</a:t>
+              <a:t>4/8/2026</a:t>
             </a:fld>
             <a:endParaRPr lang="en-US"/>
           </a:p>
@@ -1884,7 +1884,7 @@
           <a:p>
             <a:fld id="{5BCAD085-E8A6-8845-BD4E-CB4CCA059FC4}" type="datetimeFigureOut">
               <a:rPr lang="en-US" smtClean="0"/>
-              <a:t>4/7/2026</a:t>
+              <a:t>4/8/2026</a:t>
             </a:fld>
             <a:endParaRPr lang="en-US"/>
           </a:p>
@@ -1979,7 +1979,7 @@
           <a:p>
             <a:fld id="{5BCAD085-E8A6-8845-BD4E-CB4CCA059FC4}" type="datetimeFigureOut">
               <a:rPr lang="en-US" smtClean="0"/>
-              <a:t>4/7/2026</a:t>
+              <a:t>4/8/2026</a:t>
             </a:fld>
             <a:endParaRPr lang="en-US"/>
           </a:p>
@@ -2254,7 +2254,7 @@
           <a:p>
             <a:fld id="{5BCAD085-E8A6-8845-BD4E-CB4CCA059FC4}" type="datetimeFigureOut">
               <a:rPr lang="en-US" smtClean="0"/>
-              <a:t>4/7/2026</a:t>
+              <a:t>4/8/2026</a:t>
             </a:fld>
             <a:endParaRPr lang="en-US"/>
           </a:p>
@@ -2506,7 +2506,7 @@
           <a:p>
             <a:fld id="{5BCAD085-E8A6-8845-BD4E-CB4CCA059FC4}" type="datetimeFigureOut">
               <a:rPr lang="en-US" smtClean="0"/>
-              <a:t>4/7/2026</a:t>
+              <a:t>4/8/2026</a:t>
             </a:fld>
             <a:endParaRPr lang="en-US"/>
           </a:p>
@@ -2720,7 +2720,7 @@
           <a:p>
             <a:fld id="{5BCAD085-E8A6-8845-BD4E-CB4CCA059FC4}" type="datetimeFigureOut">
               <a:rPr lang="en-US" smtClean="0"/>
-              <a:t>4/7/2026</a:t>
+              <a:t>4/8/2026</a:t>
             </a:fld>
             <a:endParaRPr lang="en-US"/>
           </a:p>
@@ -3307,35 +3307,6 @@
       </p:sp>
       <p:sp>
         <p:nvSpPr>
-          <p:cNvPr id="104" name="Subtitle"/>
-          <p:cNvSpPr/>
-          <p:nvPr/>
-        </p:nvSpPr>
-        <p:spPr>
-          <a:xfrm>
-            <a:off x="355600" y="711200"/>
-            <a:ext cx="10160000" cy="254000"/>
-          </a:xfrm>
-          <a:prstGeom prst="rect">
-            <a:avLst/>
-          </a:prstGeom>
-          <a:noFill/>
-          <a:ln>
-            <a:noFill/>
-          </a:ln>
-        </p:spPr>
-        <p:txBody>
-          <a:bodyPr lIns="91440" tIns="45720" rIns="91440" bIns="45720" anchor="t"/>
-          <a:lstStyle/>
-          <a:p>
-            <a:r>
-              <a:t>Weight set selection  |  Threshold tuning  |  First live run summary</a:t>
-            </a:r>
-          </a:p>
-        </p:txBody>
-      </p:sp>
-      <p:sp>
-        <p:nvSpPr>
           <p:cNvPr id="110" name="Card Model"/>
           <p:cNvSpPr/>
           <p:nvPr/>
@@ -4073,6 +4044,60 @@
                 <a:latin typeface="Calibri"/>
               </a:rPr>
               <a:t>For radiologist review only — not for autonomous clinical decision-making  ·  TorchXRayVision DenseNet-121 + GPT-4o-mini</a:t>
+            </a:r>
+          </a:p>
+        </p:txBody>
+      </p:sp>
+      <p:sp>
+        <p:nvSpPr>
+          <p:cNvPr id="104" name="Subtitle"/>
+          <p:cNvSpPr/>
+          <p:nvPr/>
+        </p:nvSpPr>
+        <p:spPr>
+          <a:xfrm>
+            <a:off x="411967" y="647700"/>
+            <a:ext cx="10160000" cy="254000"/>
+          </a:xfrm>
+          <a:prstGeom prst="rect">
+            <a:avLst/>
+          </a:prstGeom>
+          <a:noFill/>
+          <a:ln>
+            <a:noFill/>
+          </a:ln>
+        </p:spPr>
+        <p:txBody>
+          <a:bodyPr lIns="91440" tIns="45720" rIns="91440" bIns="45720" anchor="t"/>
+          <a:lstStyle/>
+          <a:p>
+            <a:r>
+              <a:rPr sz="1100" dirty="0">
+                <a:solidFill>
+                  <a:srgbClr val="A0B4CC"/>
+                </a:solidFill>
+                <a:latin typeface="Calibri"/>
+              </a:rPr>
+              <a:t>Weight</a:t>
+            </a:r>
+            <a:r>
+              <a:rPr dirty="0">
+                <a:solidFill>
+                  <a:schemeClr val="bg1">
+                    <a:lumMod val="90000"/>
+                  </a:schemeClr>
+                </a:solidFill>
+              </a:rPr>
+              <a:t> </a:t>
+            </a:r>
+            <a:r>
+              <a:rPr sz="1100" dirty="0">
+                <a:solidFill>
+                  <a:srgbClr val="A0B4CC"/>
+                </a:solidFill>
+                <a:latin typeface="Calibri"/>
+              </a:rPr>
+              <a:t>set selection  |  Threshold tuning  |  First live run summary</a:t>
             </a:r>
           </a:p>
         </p:txBody>

</xml_diff>